<commit_message>
Atualiza nome do autor para Jacson Arruda Ribeiro na apresentacao
</commit_message>
<xml_diff>
--- a/Apresentacao_Projeto_ML.pptx
+++ b/Apresentacao_Projeto_ML.pptx
@@ -3191,7 +3191,7 @@
             </a:r>
             <a:br/>
             <a:r>
-              <a:t>Jacson — 2026</a:t>
+              <a:t>Jacson Arruda Ribeiro — 2026</a:t>
             </a:r>
           </a:p>
         </p:txBody>
@@ -7671,7 +7671,7 @@
             </a:r>
             <a:br/>
             <a:r>
-              <a:t>Jacson — UFRN — DCA3606 — 2026</a:t>
+              <a:t>Jacson Arruda Ribeiro — UFRN — DCA3606 — 2026</a:t>
             </a:r>
           </a:p>
         </p:txBody>

</xml_diff>

<commit_message>
Atualiza apresentação do projeto com novas informações
</commit_message>
<xml_diff>
--- a/Apresentacao_Projeto_ML.pptx
+++ b/Apresentacao_Projeto_ML.pptx
@@ -13161,7 +13161,7 @@
             <a:tbl>
               <a:tblPr bandRow="1" firstRow="1">
                 <a:noFill/>
-                <a:tableStyleId>{30688508-2637-413D-9EED-5CDB73259960}</a:tableStyleId>
+                <a:tableStyleId>{7F608385-1269-4C0F-9FA3-1B93938F1B1D}</a:tableStyleId>
               </a:tblPr>
               <a:tblGrid>
                 <a:gridCol w="698025"/>
@@ -15220,7 +15220,7 @@
             <a:tbl>
               <a:tblPr bandRow="1" firstRow="1">
                 <a:noFill/>
-                <a:tableStyleId>{30688508-2637-413D-9EED-5CDB73259960}</a:tableStyleId>
+                <a:tableStyleId>{7F608385-1269-4C0F-9FA3-1B93938F1B1D}</a:tableStyleId>
               </a:tblPr>
               <a:tblGrid>
                 <a:gridCol w="594250"/>
@@ -20946,7 +20946,7 @@
             <a:tbl>
               <a:tblPr bandRow="1" firstRow="1">
                 <a:noFill/>
-                <a:tableStyleId>{30688508-2637-413D-9EED-5CDB73259960}</a:tableStyleId>
+                <a:tableStyleId>{7F608385-1269-4C0F-9FA3-1B93938F1B1D}</a:tableStyleId>
               </a:tblPr>
               <a:tblGrid>
                 <a:gridCol w="1097275"/>
@@ -26976,7 +26976,7 @@
                 <a:cs typeface="Calibri"/>
                 <a:sym typeface="Calibri"/>
               </a:rPr>
-              <a:t>MedInc varia de 0.5 a 15 vs Population de 3 a 35.000 (diferença de 1000x)</a:t>
+              <a:t>MedInc(renda) varia de 0.5 a 15 vs Population de 3 a 35.000 (diferença de 1000x)</a:t>
             </a:r>
             <a:endParaRPr/>
           </a:p>

</xml_diff>